<commit_message>
Regenerate repository videos with Japanese narration
</commit_message>
<xml_diff>
--- a/public/videos/repositories/ai-quiz-study/ai-quiz-study-tech-preview.pptx
+++ b/public/videos/repositories/ai-quiz-study/ai-quiz-study-tech-preview.pptx
@@ -134,7 +134,7 @@
           <p:cNvPr id="2" name="タイトル 1">
             <a:extLst>
               <a:ext uri="{FF2B5EF4-FFF2-40B4-BE49-F238E27FC236}">
-                <a16:creationId xmlns:a16="http://schemas.microsoft.com/office/drawing/2014/main" id="{B44248C2-4CB8-673A-4790-F57FDB45B6E2}"/>
+                <a16:creationId xmlns:a16="http://schemas.microsoft.com/office/drawing/2014/main" id="{AA13A14A-B9F5-92CB-E039-363FFADFD2A0}"/>
               </a:ext>
             </a:extLst>
           </p:cNvPr>
@@ -171,7 +171,7 @@
           <p:cNvPr id="3" name="字幕 2">
             <a:extLst>
               <a:ext uri="{FF2B5EF4-FFF2-40B4-BE49-F238E27FC236}">
-                <a16:creationId xmlns:a16="http://schemas.microsoft.com/office/drawing/2014/main" id="{DF0C92CA-76F5-89B3-01D4-0D7B52843CEC}"/>
+                <a16:creationId xmlns:a16="http://schemas.microsoft.com/office/drawing/2014/main" id="{053A120E-268C-D0C8-4BC4-7306D0265CCF}"/>
               </a:ext>
             </a:extLst>
           </p:cNvPr>
@@ -241,7 +241,7 @@
           <p:cNvPr id="4" name="日付プレースホルダー 3">
             <a:extLst>
               <a:ext uri="{FF2B5EF4-FFF2-40B4-BE49-F238E27FC236}">
-                <a16:creationId xmlns:a16="http://schemas.microsoft.com/office/drawing/2014/main" id="{15794E0C-C580-8831-0C36-50C3A3662572}"/>
+                <a16:creationId xmlns:a16="http://schemas.microsoft.com/office/drawing/2014/main" id="{A8400B20-5F3E-CAEB-E9D1-D69763390511}"/>
               </a:ext>
             </a:extLst>
           </p:cNvPr>
@@ -257,7 +257,7 @@
           <a:bodyPr/>
           <a:lstStyle/>
           <a:p>
-            <a:fld id="{FE520221-3195-4EB3-B38F-EF6E1ECCD26C}" type="datetimeFigureOut">
+            <a:fld id="{1E63A22F-7DA3-4DFC-B0E7-699664E6020E}" type="datetimeFigureOut">
               <a:rPr kumimoji="1" lang="ja-JP" altLang="en-US" smtClean="0"/>
               <a:t>2026/7/30</a:t>
             </a:fld>
@@ -270,7 +270,7 @@
           <p:cNvPr id="5" name="フッター プレースホルダー 4">
             <a:extLst>
               <a:ext uri="{FF2B5EF4-FFF2-40B4-BE49-F238E27FC236}">
-                <a16:creationId xmlns:a16="http://schemas.microsoft.com/office/drawing/2014/main" id="{20F02F88-6811-4DF0-8476-BF133F09243C}"/>
+                <a16:creationId xmlns:a16="http://schemas.microsoft.com/office/drawing/2014/main" id="{6EAD118B-E96C-DA56-CBDE-A68EF820FA5C}"/>
               </a:ext>
             </a:extLst>
           </p:cNvPr>
@@ -295,7 +295,7 @@
           <p:cNvPr id="6" name="スライド番号プレースホルダー 5">
             <a:extLst>
               <a:ext uri="{FF2B5EF4-FFF2-40B4-BE49-F238E27FC236}">
-                <a16:creationId xmlns:a16="http://schemas.microsoft.com/office/drawing/2014/main" id="{E192D63E-29B1-ED93-C969-C01B330273E7}"/>
+                <a16:creationId xmlns:a16="http://schemas.microsoft.com/office/drawing/2014/main" id="{9B2E9FB5-99F1-9789-8D9C-A5DD560A79D3}"/>
               </a:ext>
             </a:extLst>
           </p:cNvPr>
@@ -311,7 +311,7 @@
           <a:bodyPr/>
           <a:lstStyle/>
           <a:p>
-            <a:fld id="{76CC2731-E6DF-4628-8FDC-A2B2A9FEE3CD}" type="slidenum">
+            <a:fld id="{A004027A-2514-4CCF-9CDD-0F55957BC748}" type="slidenum">
               <a:rPr kumimoji="1" lang="ja-JP" altLang="en-US" smtClean="0"/>
               <a:t>‹#›</a:t>
             </a:fld>
@@ -322,7 +322,7 @@
     </p:spTree>
     <p:extLst>
       <p:ext uri="{BB962C8B-B14F-4D97-AF65-F5344CB8AC3E}">
-        <p14:creationId xmlns:p14="http://schemas.microsoft.com/office/powerpoint/2010/main" val="1482501462"/>
+        <p14:creationId xmlns:p14="http://schemas.microsoft.com/office/powerpoint/2010/main" val="2175618377"/>
       </p:ext>
     </p:extLst>
   </p:cSld>
@@ -354,7 +354,7 @@
           <p:cNvPr id="2" name="タイトル 1">
             <a:extLst>
               <a:ext uri="{FF2B5EF4-FFF2-40B4-BE49-F238E27FC236}">
-                <a16:creationId xmlns:a16="http://schemas.microsoft.com/office/drawing/2014/main" id="{07FB8A9F-238D-F24C-0C31-5F2B494B17F7}"/>
+                <a16:creationId xmlns:a16="http://schemas.microsoft.com/office/drawing/2014/main" id="{078B6C07-48F4-16C6-C6F6-A2E06433E24F}"/>
               </a:ext>
             </a:extLst>
           </p:cNvPr>
@@ -382,7 +382,7 @@
           <p:cNvPr id="3" name="縦書きテキスト プレースホルダー 2">
             <a:extLst>
               <a:ext uri="{FF2B5EF4-FFF2-40B4-BE49-F238E27FC236}">
-                <a16:creationId xmlns:a16="http://schemas.microsoft.com/office/drawing/2014/main" id="{44F29887-70BE-8547-46B7-A6FA7A7C0990}"/>
+                <a16:creationId xmlns:a16="http://schemas.microsoft.com/office/drawing/2014/main" id="{8124D9D0-C48E-A216-647D-8314C9DCCAFF}"/>
               </a:ext>
             </a:extLst>
           </p:cNvPr>
@@ -471,7 +471,7 @@
           <p:cNvPr id="4" name="日付プレースホルダー 3">
             <a:extLst>
               <a:ext uri="{FF2B5EF4-FFF2-40B4-BE49-F238E27FC236}">
-                <a16:creationId xmlns:a16="http://schemas.microsoft.com/office/drawing/2014/main" id="{77A1FA18-A9EB-3E45-35E7-18148AE54632}"/>
+                <a16:creationId xmlns:a16="http://schemas.microsoft.com/office/drawing/2014/main" id="{DA9DD27F-E614-59ED-CEA2-B51D0CB91B26}"/>
               </a:ext>
             </a:extLst>
           </p:cNvPr>
@@ -487,7 +487,7 @@
           <a:bodyPr/>
           <a:lstStyle/>
           <a:p>
-            <a:fld id="{FE520221-3195-4EB3-B38F-EF6E1ECCD26C}" type="datetimeFigureOut">
+            <a:fld id="{1E63A22F-7DA3-4DFC-B0E7-699664E6020E}" type="datetimeFigureOut">
               <a:rPr kumimoji="1" lang="ja-JP" altLang="en-US" smtClean="0"/>
               <a:t>2026/7/30</a:t>
             </a:fld>
@@ -500,7 +500,7 @@
           <p:cNvPr id="5" name="フッター プレースホルダー 4">
             <a:extLst>
               <a:ext uri="{FF2B5EF4-FFF2-40B4-BE49-F238E27FC236}">
-                <a16:creationId xmlns:a16="http://schemas.microsoft.com/office/drawing/2014/main" id="{39DD4F8A-6D2E-5281-F323-4E29C0394A9A}"/>
+                <a16:creationId xmlns:a16="http://schemas.microsoft.com/office/drawing/2014/main" id="{9F30D03C-9514-F064-572C-43A4819FCA84}"/>
               </a:ext>
             </a:extLst>
           </p:cNvPr>
@@ -525,7 +525,7 @@
           <p:cNvPr id="6" name="スライド番号プレースホルダー 5">
             <a:extLst>
               <a:ext uri="{FF2B5EF4-FFF2-40B4-BE49-F238E27FC236}">
-                <a16:creationId xmlns:a16="http://schemas.microsoft.com/office/drawing/2014/main" id="{ACACF517-E4E3-2941-0881-E491760814DD}"/>
+                <a16:creationId xmlns:a16="http://schemas.microsoft.com/office/drawing/2014/main" id="{DE5B161D-7CDD-859C-4909-021C5B78EE78}"/>
               </a:ext>
             </a:extLst>
           </p:cNvPr>
@@ -541,7 +541,7 @@
           <a:bodyPr/>
           <a:lstStyle/>
           <a:p>
-            <a:fld id="{76CC2731-E6DF-4628-8FDC-A2B2A9FEE3CD}" type="slidenum">
+            <a:fld id="{A004027A-2514-4CCF-9CDD-0F55957BC748}" type="slidenum">
               <a:rPr kumimoji="1" lang="ja-JP" altLang="en-US" smtClean="0"/>
               <a:t>‹#›</a:t>
             </a:fld>
@@ -552,7 +552,7 @@
     </p:spTree>
     <p:extLst>
       <p:ext uri="{BB962C8B-B14F-4D97-AF65-F5344CB8AC3E}">
-        <p14:creationId xmlns:p14="http://schemas.microsoft.com/office/powerpoint/2010/main" val="2748629732"/>
+        <p14:creationId xmlns:p14="http://schemas.microsoft.com/office/powerpoint/2010/main" val="3940540443"/>
       </p:ext>
     </p:extLst>
   </p:cSld>
@@ -584,7 +584,7 @@
           <p:cNvPr id="2" name="縦書きタイトル 1">
             <a:extLst>
               <a:ext uri="{FF2B5EF4-FFF2-40B4-BE49-F238E27FC236}">
-                <a16:creationId xmlns:a16="http://schemas.microsoft.com/office/drawing/2014/main" id="{B43B986C-AF3A-B1E9-45BC-9326FFD5EA27}"/>
+                <a16:creationId xmlns:a16="http://schemas.microsoft.com/office/drawing/2014/main" id="{CFE5B169-4332-FDE3-7337-234F0E72D3DC}"/>
               </a:ext>
             </a:extLst>
           </p:cNvPr>
@@ -617,7 +617,7 @@
           <p:cNvPr id="3" name="縦書きテキスト プレースホルダー 2">
             <a:extLst>
               <a:ext uri="{FF2B5EF4-FFF2-40B4-BE49-F238E27FC236}">
-                <a16:creationId xmlns:a16="http://schemas.microsoft.com/office/drawing/2014/main" id="{05EF9AC1-4D35-5569-3F51-D87D66735E7B}"/>
+                <a16:creationId xmlns:a16="http://schemas.microsoft.com/office/drawing/2014/main" id="{84E1896A-2A76-CB75-13A6-B7861194469B}"/>
               </a:ext>
             </a:extLst>
           </p:cNvPr>
@@ -711,7 +711,7 @@
           <p:cNvPr id="4" name="日付プレースホルダー 3">
             <a:extLst>
               <a:ext uri="{FF2B5EF4-FFF2-40B4-BE49-F238E27FC236}">
-                <a16:creationId xmlns:a16="http://schemas.microsoft.com/office/drawing/2014/main" id="{9B1190DE-49CA-5BBB-776B-E8447065D120}"/>
+                <a16:creationId xmlns:a16="http://schemas.microsoft.com/office/drawing/2014/main" id="{BBAA583E-F6D1-B932-4726-E4A7859DC7C1}"/>
               </a:ext>
             </a:extLst>
           </p:cNvPr>
@@ -727,7 +727,7 @@
           <a:bodyPr/>
           <a:lstStyle/>
           <a:p>
-            <a:fld id="{FE520221-3195-4EB3-B38F-EF6E1ECCD26C}" type="datetimeFigureOut">
+            <a:fld id="{1E63A22F-7DA3-4DFC-B0E7-699664E6020E}" type="datetimeFigureOut">
               <a:rPr kumimoji="1" lang="ja-JP" altLang="en-US" smtClean="0"/>
               <a:t>2026/7/30</a:t>
             </a:fld>
@@ -740,7 +740,7 @@
           <p:cNvPr id="5" name="フッター プレースホルダー 4">
             <a:extLst>
               <a:ext uri="{FF2B5EF4-FFF2-40B4-BE49-F238E27FC236}">
-                <a16:creationId xmlns:a16="http://schemas.microsoft.com/office/drawing/2014/main" id="{E7AAD48F-E7D3-868A-9043-5DA9E38D849F}"/>
+                <a16:creationId xmlns:a16="http://schemas.microsoft.com/office/drawing/2014/main" id="{E31F0711-4839-6746-B13A-63242C407DA8}"/>
               </a:ext>
             </a:extLst>
           </p:cNvPr>
@@ -765,7 +765,7 @@
           <p:cNvPr id="6" name="スライド番号プレースホルダー 5">
             <a:extLst>
               <a:ext uri="{FF2B5EF4-FFF2-40B4-BE49-F238E27FC236}">
-                <a16:creationId xmlns:a16="http://schemas.microsoft.com/office/drawing/2014/main" id="{5CEE8484-F50F-58DA-C2D6-FF12E28CFB8B}"/>
+                <a16:creationId xmlns:a16="http://schemas.microsoft.com/office/drawing/2014/main" id="{15EC4247-FC31-83E9-E67D-B9AED5050626}"/>
               </a:ext>
             </a:extLst>
           </p:cNvPr>
@@ -781,7 +781,7 @@
           <a:bodyPr/>
           <a:lstStyle/>
           <a:p>
-            <a:fld id="{76CC2731-E6DF-4628-8FDC-A2B2A9FEE3CD}" type="slidenum">
+            <a:fld id="{A004027A-2514-4CCF-9CDD-0F55957BC748}" type="slidenum">
               <a:rPr kumimoji="1" lang="ja-JP" altLang="en-US" smtClean="0"/>
               <a:t>‹#›</a:t>
             </a:fld>
@@ -792,7 +792,7 @@
     </p:spTree>
     <p:extLst>
       <p:ext uri="{BB962C8B-B14F-4D97-AF65-F5344CB8AC3E}">
-        <p14:creationId xmlns:p14="http://schemas.microsoft.com/office/powerpoint/2010/main" val="1157920540"/>
+        <p14:creationId xmlns:p14="http://schemas.microsoft.com/office/powerpoint/2010/main" val="3502140561"/>
       </p:ext>
     </p:extLst>
   </p:cSld>
@@ -824,7 +824,7 @@
           <p:cNvPr id="2" name="タイトル 1">
             <a:extLst>
               <a:ext uri="{FF2B5EF4-FFF2-40B4-BE49-F238E27FC236}">
-                <a16:creationId xmlns:a16="http://schemas.microsoft.com/office/drawing/2014/main" id="{EBE74513-3EC4-B204-6D64-4027DCE2EF30}"/>
+                <a16:creationId xmlns:a16="http://schemas.microsoft.com/office/drawing/2014/main" id="{96F70146-65B9-28E5-F1C0-5902ADC3C8C3}"/>
               </a:ext>
             </a:extLst>
           </p:cNvPr>
@@ -852,7 +852,7 @@
           <p:cNvPr id="3" name="コンテンツ プレースホルダー 2">
             <a:extLst>
               <a:ext uri="{FF2B5EF4-FFF2-40B4-BE49-F238E27FC236}">
-                <a16:creationId xmlns:a16="http://schemas.microsoft.com/office/drawing/2014/main" id="{E9DDEE3A-456B-F82F-CB67-536697B33CE0}"/>
+                <a16:creationId xmlns:a16="http://schemas.microsoft.com/office/drawing/2014/main" id="{D131B020-B6F2-B402-791A-A6821E9F67C3}"/>
               </a:ext>
             </a:extLst>
           </p:cNvPr>
@@ -941,7 +941,7 @@
           <p:cNvPr id="4" name="日付プレースホルダー 3">
             <a:extLst>
               <a:ext uri="{FF2B5EF4-FFF2-40B4-BE49-F238E27FC236}">
-                <a16:creationId xmlns:a16="http://schemas.microsoft.com/office/drawing/2014/main" id="{D46F7123-1DE5-1BF4-7AB0-8F6F37C7003E}"/>
+                <a16:creationId xmlns:a16="http://schemas.microsoft.com/office/drawing/2014/main" id="{4FE03E6B-8B65-8851-45CE-D014B72F2E60}"/>
               </a:ext>
             </a:extLst>
           </p:cNvPr>
@@ -957,7 +957,7 @@
           <a:bodyPr/>
           <a:lstStyle/>
           <a:p>
-            <a:fld id="{FE520221-3195-4EB3-B38F-EF6E1ECCD26C}" type="datetimeFigureOut">
+            <a:fld id="{1E63A22F-7DA3-4DFC-B0E7-699664E6020E}" type="datetimeFigureOut">
               <a:rPr kumimoji="1" lang="ja-JP" altLang="en-US" smtClean="0"/>
               <a:t>2026/7/30</a:t>
             </a:fld>
@@ -970,7 +970,7 @@
           <p:cNvPr id="5" name="フッター プレースホルダー 4">
             <a:extLst>
               <a:ext uri="{FF2B5EF4-FFF2-40B4-BE49-F238E27FC236}">
-                <a16:creationId xmlns:a16="http://schemas.microsoft.com/office/drawing/2014/main" id="{3DE7F4BE-62B7-3ABB-D462-9A616E62C23B}"/>
+                <a16:creationId xmlns:a16="http://schemas.microsoft.com/office/drawing/2014/main" id="{A26509F1-81A2-6C56-6760-E65CD5AE0462}"/>
               </a:ext>
             </a:extLst>
           </p:cNvPr>
@@ -995,7 +995,7 @@
           <p:cNvPr id="6" name="スライド番号プレースホルダー 5">
             <a:extLst>
               <a:ext uri="{FF2B5EF4-FFF2-40B4-BE49-F238E27FC236}">
-                <a16:creationId xmlns:a16="http://schemas.microsoft.com/office/drawing/2014/main" id="{236B3C88-E215-D407-8427-42D378F02A1B}"/>
+                <a16:creationId xmlns:a16="http://schemas.microsoft.com/office/drawing/2014/main" id="{5023DB41-15E7-CF98-722B-03FADCAAE65E}"/>
               </a:ext>
             </a:extLst>
           </p:cNvPr>
@@ -1011,7 +1011,7 @@
           <a:bodyPr/>
           <a:lstStyle/>
           <a:p>
-            <a:fld id="{76CC2731-E6DF-4628-8FDC-A2B2A9FEE3CD}" type="slidenum">
+            <a:fld id="{A004027A-2514-4CCF-9CDD-0F55957BC748}" type="slidenum">
               <a:rPr kumimoji="1" lang="ja-JP" altLang="en-US" smtClean="0"/>
               <a:t>‹#›</a:t>
             </a:fld>
@@ -1022,7 +1022,7 @@
     </p:spTree>
     <p:extLst>
       <p:ext uri="{BB962C8B-B14F-4D97-AF65-F5344CB8AC3E}">
-        <p14:creationId xmlns:p14="http://schemas.microsoft.com/office/powerpoint/2010/main" val="1790736096"/>
+        <p14:creationId xmlns:p14="http://schemas.microsoft.com/office/powerpoint/2010/main" val="836025184"/>
       </p:ext>
     </p:extLst>
   </p:cSld>
@@ -1054,7 +1054,7 @@
           <p:cNvPr id="2" name="タイトル 1">
             <a:extLst>
               <a:ext uri="{FF2B5EF4-FFF2-40B4-BE49-F238E27FC236}">
-                <a16:creationId xmlns:a16="http://schemas.microsoft.com/office/drawing/2014/main" id="{2E7BCFB3-FA84-4E97-A225-80983BFA159E}"/>
+                <a16:creationId xmlns:a16="http://schemas.microsoft.com/office/drawing/2014/main" id="{F36930A0-5E45-3F0C-A636-8BC11DA878E9}"/>
               </a:ext>
             </a:extLst>
           </p:cNvPr>
@@ -1091,7 +1091,7 @@
           <p:cNvPr id="3" name="テキスト プレースホルダー 2">
             <a:extLst>
               <a:ext uri="{FF2B5EF4-FFF2-40B4-BE49-F238E27FC236}">
-                <a16:creationId xmlns:a16="http://schemas.microsoft.com/office/drawing/2014/main" id="{5AD39018-F0C5-A717-32B4-64FD87408CFD}"/>
+                <a16:creationId xmlns:a16="http://schemas.microsoft.com/office/drawing/2014/main" id="{FA189305-376B-782B-FB57-EB289C0F28DE}"/>
               </a:ext>
             </a:extLst>
           </p:cNvPr>
@@ -1216,7 +1216,7 @@
           <p:cNvPr id="4" name="日付プレースホルダー 3">
             <a:extLst>
               <a:ext uri="{FF2B5EF4-FFF2-40B4-BE49-F238E27FC236}">
-                <a16:creationId xmlns:a16="http://schemas.microsoft.com/office/drawing/2014/main" id="{62CC7649-C07D-3839-A016-52492629A9BF}"/>
+                <a16:creationId xmlns:a16="http://schemas.microsoft.com/office/drawing/2014/main" id="{8DE41351-A904-08DE-4289-0F42BB0541C4}"/>
               </a:ext>
             </a:extLst>
           </p:cNvPr>
@@ -1232,7 +1232,7 @@
           <a:bodyPr/>
           <a:lstStyle/>
           <a:p>
-            <a:fld id="{FE520221-3195-4EB3-B38F-EF6E1ECCD26C}" type="datetimeFigureOut">
+            <a:fld id="{1E63A22F-7DA3-4DFC-B0E7-699664E6020E}" type="datetimeFigureOut">
               <a:rPr kumimoji="1" lang="ja-JP" altLang="en-US" smtClean="0"/>
               <a:t>2026/7/30</a:t>
             </a:fld>
@@ -1245,7 +1245,7 @@
           <p:cNvPr id="5" name="フッター プレースホルダー 4">
             <a:extLst>
               <a:ext uri="{FF2B5EF4-FFF2-40B4-BE49-F238E27FC236}">
-                <a16:creationId xmlns:a16="http://schemas.microsoft.com/office/drawing/2014/main" id="{537E3EC6-EEEB-0074-B413-AF17C8CD303C}"/>
+                <a16:creationId xmlns:a16="http://schemas.microsoft.com/office/drawing/2014/main" id="{430F4D92-DFB6-66E9-B105-2CADCBADE156}"/>
               </a:ext>
             </a:extLst>
           </p:cNvPr>
@@ -1270,7 +1270,7 @@
           <p:cNvPr id="6" name="スライド番号プレースホルダー 5">
             <a:extLst>
               <a:ext uri="{FF2B5EF4-FFF2-40B4-BE49-F238E27FC236}">
-                <a16:creationId xmlns:a16="http://schemas.microsoft.com/office/drawing/2014/main" id="{B6D7AB9B-6851-EC7B-759B-DCEB3DB70E6B}"/>
+                <a16:creationId xmlns:a16="http://schemas.microsoft.com/office/drawing/2014/main" id="{22998F6E-EE1C-6EF0-8E8D-D33D6D42951A}"/>
               </a:ext>
             </a:extLst>
           </p:cNvPr>
@@ -1286,7 +1286,7 @@
           <a:bodyPr/>
           <a:lstStyle/>
           <a:p>
-            <a:fld id="{76CC2731-E6DF-4628-8FDC-A2B2A9FEE3CD}" type="slidenum">
+            <a:fld id="{A004027A-2514-4CCF-9CDD-0F55957BC748}" type="slidenum">
               <a:rPr kumimoji="1" lang="ja-JP" altLang="en-US" smtClean="0"/>
               <a:t>‹#›</a:t>
             </a:fld>
@@ -1297,7 +1297,7 @@
     </p:spTree>
     <p:extLst>
       <p:ext uri="{BB962C8B-B14F-4D97-AF65-F5344CB8AC3E}">
-        <p14:creationId xmlns:p14="http://schemas.microsoft.com/office/powerpoint/2010/main" val="3015789121"/>
+        <p14:creationId xmlns:p14="http://schemas.microsoft.com/office/powerpoint/2010/main" val="288416672"/>
       </p:ext>
     </p:extLst>
   </p:cSld>
@@ -1329,7 +1329,7 @@
           <p:cNvPr id="2" name="タイトル 1">
             <a:extLst>
               <a:ext uri="{FF2B5EF4-FFF2-40B4-BE49-F238E27FC236}">
-                <a16:creationId xmlns:a16="http://schemas.microsoft.com/office/drawing/2014/main" id="{D5CA6432-D0AC-6D1C-C0C5-590205E8FCEC}"/>
+                <a16:creationId xmlns:a16="http://schemas.microsoft.com/office/drawing/2014/main" id="{DA4B7AE9-843D-4E99-1FF6-74E2B9D544EC}"/>
               </a:ext>
             </a:extLst>
           </p:cNvPr>
@@ -1357,7 +1357,7 @@
           <p:cNvPr id="3" name="コンテンツ プレースホルダー 2">
             <a:extLst>
               <a:ext uri="{FF2B5EF4-FFF2-40B4-BE49-F238E27FC236}">
-                <a16:creationId xmlns:a16="http://schemas.microsoft.com/office/drawing/2014/main" id="{F82120BD-D752-79AA-4030-3AC7D57DE197}"/>
+                <a16:creationId xmlns:a16="http://schemas.microsoft.com/office/drawing/2014/main" id="{A0C5BC50-1F16-11A2-CD7F-FF1083532BBF}"/>
               </a:ext>
             </a:extLst>
           </p:cNvPr>
@@ -1451,7 +1451,7 @@
           <p:cNvPr id="4" name="コンテンツ プレースホルダー 3">
             <a:extLst>
               <a:ext uri="{FF2B5EF4-FFF2-40B4-BE49-F238E27FC236}">
-                <a16:creationId xmlns:a16="http://schemas.microsoft.com/office/drawing/2014/main" id="{F8C15555-55D0-D937-94FE-184A3246A15B}"/>
+                <a16:creationId xmlns:a16="http://schemas.microsoft.com/office/drawing/2014/main" id="{D8A5F892-6176-7463-6BD8-FE577C0E85ED}"/>
               </a:ext>
             </a:extLst>
           </p:cNvPr>
@@ -1545,7 +1545,7 @@
           <p:cNvPr id="5" name="日付プレースホルダー 4">
             <a:extLst>
               <a:ext uri="{FF2B5EF4-FFF2-40B4-BE49-F238E27FC236}">
-                <a16:creationId xmlns:a16="http://schemas.microsoft.com/office/drawing/2014/main" id="{C85F61AD-DBE6-64C6-BC13-47EB1162644B}"/>
+                <a16:creationId xmlns:a16="http://schemas.microsoft.com/office/drawing/2014/main" id="{B514FCD3-26A8-F1E3-6C1F-E58D2C3CD906}"/>
               </a:ext>
             </a:extLst>
           </p:cNvPr>
@@ -1561,7 +1561,7 @@
           <a:bodyPr/>
           <a:lstStyle/>
           <a:p>
-            <a:fld id="{FE520221-3195-4EB3-B38F-EF6E1ECCD26C}" type="datetimeFigureOut">
+            <a:fld id="{1E63A22F-7DA3-4DFC-B0E7-699664E6020E}" type="datetimeFigureOut">
               <a:rPr kumimoji="1" lang="ja-JP" altLang="en-US" smtClean="0"/>
               <a:t>2026/7/30</a:t>
             </a:fld>
@@ -1574,7 +1574,7 @@
           <p:cNvPr id="6" name="フッター プレースホルダー 5">
             <a:extLst>
               <a:ext uri="{FF2B5EF4-FFF2-40B4-BE49-F238E27FC236}">
-                <a16:creationId xmlns:a16="http://schemas.microsoft.com/office/drawing/2014/main" id="{028A5F8A-6908-E19B-3EED-52552F5FA9C1}"/>
+                <a16:creationId xmlns:a16="http://schemas.microsoft.com/office/drawing/2014/main" id="{D5F8D757-CB9C-D21F-535C-9FD7ECA03408}"/>
               </a:ext>
             </a:extLst>
           </p:cNvPr>
@@ -1599,7 +1599,7 @@
           <p:cNvPr id="7" name="スライド番号プレースホルダー 6">
             <a:extLst>
               <a:ext uri="{FF2B5EF4-FFF2-40B4-BE49-F238E27FC236}">
-                <a16:creationId xmlns:a16="http://schemas.microsoft.com/office/drawing/2014/main" id="{CBFEA13A-680C-B0A9-C003-75813B4A57A1}"/>
+                <a16:creationId xmlns:a16="http://schemas.microsoft.com/office/drawing/2014/main" id="{D6E6B097-FCAF-E40F-F971-21D28F560D24}"/>
               </a:ext>
             </a:extLst>
           </p:cNvPr>
@@ -1615,7 +1615,7 @@
           <a:bodyPr/>
           <a:lstStyle/>
           <a:p>
-            <a:fld id="{76CC2731-E6DF-4628-8FDC-A2B2A9FEE3CD}" type="slidenum">
+            <a:fld id="{A004027A-2514-4CCF-9CDD-0F55957BC748}" type="slidenum">
               <a:rPr kumimoji="1" lang="ja-JP" altLang="en-US" smtClean="0"/>
               <a:t>‹#›</a:t>
             </a:fld>
@@ -1626,7 +1626,7 @@
     </p:spTree>
     <p:extLst>
       <p:ext uri="{BB962C8B-B14F-4D97-AF65-F5344CB8AC3E}">
-        <p14:creationId xmlns:p14="http://schemas.microsoft.com/office/powerpoint/2010/main" val="1047446786"/>
+        <p14:creationId xmlns:p14="http://schemas.microsoft.com/office/powerpoint/2010/main" val="2198884009"/>
       </p:ext>
     </p:extLst>
   </p:cSld>
@@ -1658,7 +1658,7 @@
           <p:cNvPr id="2" name="タイトル 1">
             <a:extLst>
               <a:ext uri="{FF2B5EF4-FFF2-40B4-BE49-F238E27FC236}">
-                <a16:creationId xmlns:a16="http://schemas.microsoft.com/office/drawing/2014/main" id="{7F7B8738-8EBD-643F-9F17-E40017EC80CF}"/>
+                <a16:creationId xmlns:a16="http://schemas.microsoft.com/office/drawing/2014/main" id="{A4FF6428-DC20-0A4E-A708-A0807E217C9E}"/>
               </a:ext>
             </a:extLst>
           </p:cNvPr>
@@ -1691,7 +1691,7 @@
           <p:cNvPr id="3" name="テキスト プレースホルダー 2">
             <a:extLst>
               <a:ext uri="{FF2B5EF4-FFF2-40B4-BE49-F238E27FC236}">
-                <a16:creationId xmlns:a16="http://schemas.microsoft.com/office/drawing/2014/main" id="{DB2E8D48-0940-A636-C163-710246099588}"/>
+                <a16:creationId xmlns:a16="http://schemas.microsoft.com/office/drawing/2014/main" id="{711A3BED-D068-439A-39BF-F1C143FE20BE}"/>
               </a:ext>
             </a:extLst>
           </p:cNvPr>
@@ -1762,7 +1762,7 @@
           <p:cNvPr id="4" name="コンテンツ プレースホルダー 3">
             <a:extLst>
               <a:ext uri="{FF2B5EF4-FFF2-40B4-BE49-F238E27FC236}">
-                <a16:creationId xmlns:a16="http://schemas.microsoft.com/office/drawing/2014/main" id="{2581AA50-DA65-E707-5D61-1DB24E1E93E7}"/>
+                <a16:creationId xmlns:a16="http://schemas.microsoft.com/office/drawing/2014/main" id="{9E256FE1-7DE2-71E5-37C6-F85B897D8364}"/>
               </a:ext>
             </a:extLst>
           </p:cNvPr>
@@ -1856,7 +1856,7 @@
           <p:cNvPr id="5" name="テキスト プレースホルダー 4">
             <a:extLst>
               <a:ext uri="{FF2B5EF4-FFF2-40B4-BE49-F238E27FC236}">
-                <a16:creationId xmlns:a16="http://schemas.microsoft.com/office/drawing/2014/main" id="{7DFCA878-23FB-9B40-033B-9C96558A7A20}"/>
+                <a16:creationId xmlns:a16="http://schemas.microsoft.com/office/drawing/2014/main" id="{C4CAE12C-2B84-C78A-BAB5-89B48B6C8B79}"/>
               </a:ext>
             </a:extLst>
           </p:cNvPr>
@@ -1927,7 +1927,7 @@
           <p:cNvPr id="6" name="コンテンツ プレースホルダー 5">
             <a:extLst>
               <a:ext uri="{FF2B5EF4-FFF2-40B4-BE49-F238E27FC236}">
-                <a16:creationId xmlns:a16="http://schemas.microsoft.com/office/drawing/2014/main" id="{1A6D76FA-ABEA-7477-6E54-C6AA4F6EA25B}"/>
+                <a16:creationId xmlns:a16="http://schemas.microsoft.com/office/drawing/2014/main" id="{B62FC1C0-3C3E-FA67-8458-610BD3DA91BD}"/>
               </a:ext>
             </a:extLst>
           </p:cNvPr>
@@ -2021,7 +2021,7 @@
           <p:cNvPr id="7" name="日付プレースホルダー 6">
             <a:extLst>
               <a:ext uri="{FF2B5EF4-FFF2-40B4-BE49-F238E27FC236}">
-                <a16:creationId xmlns:a16="http://schemas.microsoft.com/office/drawing/2014/main" id="{73E6376E-100F-6034-6832-C0397BABABC8}"/>
+                <a16:creationId xmlns:a16="http://schemas.microsoft.com/office/drawing/2014/main" id="{87C3F4A4-2BEE-D33D-D0B3-767045E5EF88}"/>
               </a:ext>
             </a:extLst>
           </p:cNvPr>
@@ -2037,7 +2037,7 @@
           <a:bodyPr/>
           <a:lstStyle/>
           <a:p>
-            <a:fld id="{FE520221-3195-4EB3-B38F-EF6E1ECCD26C}" type="datetimeFigureOut">
+            <a:fld id="{1E63A22F-7DA3-4DFC-B0E7-699664E6020E}" type="datetimeFigureOut">
               <a:rPr kumimoji="1" lang="ja-JP" altLang="en-US" smtClean="0"/>
               <a:t>2026/7/30</a:t>
             </a:fld>
@@ -2050,7 +2050,7 @@
           <p:cNvPr id="8" name="フッター プレースホルダー 7">
             <a:extLst>
               <a:ext uri="{FF2B5EF4-FFF2-40B4-BE49-F238E27FC236}">
-                <a16:creationId xmlns:a16="http://schemas.microsoft.com/office/drawing/2014/main" id="{FCE2D7D3-F24C-E090-1AA4-7BE44ECE3AD8}"/>
+                <a16:creationId xmlns:a16="http://schemas.microsoft.com/office/drawing/2014/main" id="{1FAF3CD4-36CC-DCC4-8BAD-53CDD82C1B51}"/>
               </a:ext>
             </a:extLst>
           </p:cNvPr>
@@ -2075,7 +2075,7 @@
           <p:cNvPr id="9" name="スライド番号プレースホルダー 8">
             <a:extLst>
               <a:ext uri="{FF2B5EF4-FFF2-40B4-BE49-F238E27FC236}">
-                <a16:creationId xmlns:a16="http://schemas.microsoft.com/office/drawing/2014/main" id="{BA52D8C2-1AA6-0143-7BDE-6B0848F6A5C1}"/>
+                <a16:creationId xmlns:a16="http://schemas.microsoft.com/office/drawing/2014/main" id="{E7D5B507-9E0B-CDFA-DC15-079978EBB5DC}"/>
               </a:ext>
             </a:extLst>
           </p:cNvPr>
@@ -2091,7 +2091,7 @@
           <a:bodyPr/>
           <a:lstStyle/>
           <a:p>
-            <a:fld id="{76CC2731-E6DF-4628-8FDC-A2B2A9FEE3CD}" type="slidenum">
+            <a:fld id="{A004027A-2514-4CCF-9CDD-0F55957BC748}" type="slidenum">
               <a:rPr kumimoji="1" lang="ja-JP" altLang="en-US" smtClean="0"/>
               <a:t>‹#›</a:t>
             </a:fld>
@@ -2102,7 +2102,7 @@
     </p:spTree>
     <p:extLst>
       <p:ext uri="{BB962C8B-B14F-4D97-AF65-F5344CB8AC3E}">
-        <p14:creationId xmlns:p14="http://schemas.microsoft.com/office/powerpoint/2010/main" val="2121323359"/>
+        <p14:creationId xmlns:p14="http://schemas.microsoft.com/office/powerpoint/2010/main" val="3411532618"/>
       </p:ext>
     </p:extLst>
   </p:cSld>
@@ -2134,7 +2134,7 @@
           <p:cNvPr id="2" name="タイトル 1">
             <a:extLst>
               <a:ext uri="{FF2B5EF4-FFF2-40B4-BE49-F238E27FC236}">
-                <a16:creationId xmlns:a16="http://schemas.microsoft.com/office/drawing/2014/main" id="{9B5A21E6-B07E-5669-7E01-A283EFD80E91}"/>
+                <a16:creationId xmlns:a16="http://schemas.microsoft.com/office/drawing/2014/main" id="{1043B3A1-7B7C-F017-0FD6-7F0ACE204BCA}"/>
               </a:ext>
             </a:extLst>
           </p:cNvPr>
@@ -2162,7 +2162,7 @@
           <p:cNvPr id="3" name="日付プレースホルダー 2">
             <a:extLst>
               <a:ext uri="{FF2B5EF4-FFF2-40B4-BE49-F238E27FC236}">
-                <a16:creationId xmlns:a16="http://schemas.microsoft.com/office/drawing/2014/main" id="{5187B7E4-B26B-B5DF-E750-2876F0DB0B90}"/>
+                <a16:creationId xmlns:a16="http://schemas.microsoft.com/office/drawing/2014/main" id="{771E7D5F-55B6-3B32-EF13-86280AFD6E68}"/>
               </a:ext>
             </a:extLst>
           </p:cNvPr>
@@ -2178,7 +2178,7 @@
           <a:bodyPr/>
           <a:lstStyle/>
           <a:p>
-            <a:fld id="{FE520221-3195-4EB3-B38F-EF6E1ECCD26C}" type="datetimeFigureOut">
+            <a:fld id="{1E63A22F-7DA3-4DFC-B0E7-699664E6020E}" type="datetimeFigureOut">
               <a:rPr kumimoji="1" lang="ja-JP" altLang="en-US" smtClean="0"/>
               <a:t>2026/7/30</a:t>
             </a:fld>
@@ -2191,7 +2191,7 @@
           <p:cNvPr id="4" name="フッター プレースホルダー 3">
             <a:extLst>
               <a:ext uri="{FF2B5EF4-FFF2-40B4-BE49-F238E27FC236}">
-                <a16:creationId xmlns:a16="http://schemas.microsoft.com/office/drawing/2014/main" id="{04FF5697-AE65-69C3-D5D9-BE25D5DEECA3}"/>
+                <a16:creationId xmlns:a16="http://schemas.microsoft.com/office/drawing/2014/main" id="{6D1BF1F5-5C66-A141-EE48-8492F3F1311C}"/>
               </a:ext>
             </a:extLst>
           </p:cNvPr>
@@ -2216,7 +2216,7 @@
           <p:cNvPr id="5" name="スライド番号プレースホルダー 4">
             <a:extLst>
               <a:ext uri="{FF2B5EF4-FFF2-40B4-BE49-F238E27FC236}">
-                <a16:creationId xmlns:a16="http://schemas.microsoft.com/office/drawing/2014/main" id="{6E9AB704-429B-B95C-FB51-F4164B74C734}"/>
+                <a16:creationId xmlns:a16="http://schemas.microsoft.com/office/drawing/2014/main" id="{CB1E3E59-6442-406C-3BDA-E3A599CFE924}"/>
               </a:ext>
             </a:extLst>
           </p:cNvPr>
@@ -2232,7 +2232,7 @@
           <a:bodyPr/>
           <a:lstStyle/>
           <a:p>
-            <a:fld id="{76CC2731-E6DF-4628-8FDC-A2B2A9FEE3CD}" type="slidenum">
+            <a:fld id="{A004027A-2514-4CCF-9CDD-0F55957BC748}" type="slidenum">
               <a:rPr kumimoji="1" lang="ja-JP" altLang="en-US" smtClean="0"/>
               <a:t>‹#›</a:t>
             </a:fld>
@@ -2243,7 +2243,7 @@
     </p:spTree>
     <p:extLst>
       <p:ext uri="{BB962C8B-B14F-4D97-AF65-F5344CB8AC3E}">
-        <p14:creationId xmlns:p14="http://schemas.microsoft.com/office/powerpoint/2010/main" val="827196400"/>
+        <p14:creationId xmlns:p14="http://schemas.microsoft.com/office/powerpoint/2010/main" val="1661789522"/>
       </p:ext>
     </p:extLst>
   </p:cSld>
@@ -2275,7 +2275,7 @@
           <p:cNvPr id="2" name="日付プレースホルダー 1">
             <a:extLst>
               <a:ext uri="{FF2B5EF4-FFF2-40B4-BE49-F238E27FC236}">
-                <a16:creationId xmlns:a16="http://schemas.microsoft.com/office/drawing/2014/main" id="{D19880A8-044C-3401-4DD9-91D219ADFC8D}"/>
+                <a16:creationId xmlns:a16="http://schemas.microsoft.com/office/drawing/2014/main" id="{ECF4810F-9CC4-E5CB-8723-705918E88A93}"/>
               </a:ext>
             </a:extLst>
           </p:cNvPr>
@@ -2291,7 +2291,7 @@
           <a:bodyPr/>
           <a:lstStyle/>
           <a:p>
-            <a:fld id="{FE520221-3195-4EB3-B38F-EF6E1ECCD26C}" type="datetimeFigureOut">
+            <a:fld id="{1E63A22F-7DA3-4DFC-B0E7-699664E6020E}" type="datetimeFigureOut">
               <a:rPr kumimoji="1" lang="ja-JP" altLang="en-US" smtClean="0"/>
               <a:t>2026/7/30</a:t>
             </a:fld>
@@ -2304,7 +2304,7 @@
           <p:cNvPr id="3" name="フッター プレースホルダー 2">
             <a:extLst>
               <a:ext uri="{FF2B5EF4-FFF2-40B4-BE49-F238E27FC236}">
-                <a16:creationId xmlns:a16="http://schemas.microsoft.com/office/drawing/2014/main" id="{CCDC4054-BBB1-3FB3-84AF-4260489A9E0F}"/>
+                <a16:creationId xmlns:a16="http://schemas.microsoft.com/office/drawing/2014/main" id="{12577CAF-C494-236D-1BF1-96998BCAFA75}"/>
               </a:ext>
             </a:extLst>
           </p:cNvPr>
@@ -2329,7 +2329,7 @@
           <p:cNvPr id="4" name="スライド番号プレースホルダー 3">
             <a:extLst>
               <a:ext uri="{FF2B5EF4-FFF2-40B4-BE49-F238E27FC236}">
-                <a16:creationId xmlns:a16="http://schemas.microsoft.com/office/drawing/2014/main" id="{321408ED-809A-9BA2-991F-3C05D01ED277}"/>
+                <a16:creationId xmlns:a16="http://schemas.microsoft.com/office/drawing/2014/main" id="{9E831D22-BD1A-F468-811E-B7DF1021D6CF}"/>
               </a:ext>
             </a:extLst>
           </p:cNvPr>
@@ -2345,7 +2345,7 @@
           <a:bodyPr/>
           <a:lstStyle/>
           <a:p>
-            <a:fld id="{76CC2731-E6DF-4628-8FDC-A2B2A9FEE3CD}" type="slidenum">
+            <a:fld id="{A004027A-2514-4CCF-9CDD-0F55957BC748}" type="slidenum">
               <a:rPr kumimoji="1" lang="ja-JP" altLang="en-US" smtClean="0"/>
               <a:t>‹#›</a:t>
             </a:fld>
@@ -2356,7 +2356,7 @@
     </p:spTree>
     <p:extLst>
       <p:ext uri="{BB962C8B-B14F-4D97-AF65-F5344CB8AC3E}">
-        <p14:creationId xmlns:p14="http://schemas.microsoft.com/office/powerpoint/2010/main" val="333866069"/>
+        <p14:creationId xmlns:p14="http://schemas.microsoft.com/office/powerpoint/2010/main" val="3815705339"/>
       </p:ext>
     </p:extLst>
   </p:cSld>
@@ -2388,7 +2388,7 @@
           <p:cNvPr id="2" name="タイトル 1">
             <a:extLst>
               <a:ext uri="{FF2B5EF4-FFF2-40B4-BE49-F238E27FC236}">
-                <a16:creationId xmlns:a16="http://schemas.microsoft.com/office/drawing/2014/main" id="{D9C6DF20-8982-0860-E9EF-11051DFD3FCF}"/>
+                <a16:creationId xmlns:a16="http://schemas.microsoft.com/office/drawing/2014/main" id="{81F89D15-4B5F-302A-3765-02BE48F4D82E}"/>
               </a:ext>
             </a:extLst>
           </p:cNvPr>
@@ -2425,7 +2425,7 @@
           <p:cNvPr id="3" name="コンテンツ プレースホルダー 2">
             <a:extLst>
               <a:ext uri="{FF2B5EF4-FFF2-40B4-BE49-F238E27FC236}">
-                <a16:creationId xmlns:a16="http://schemas.microsoft.com/office/drawing/2014/main" id="{55CBC9EF-05B0-26F8-1E83-FC9262D2CE8B}"/>
+                <a16:creationId xmlns:a16="http://schemas.microsoft.com/office/drawing/2014/main" id="{1B0C81CE-78F8-DF55-8E50-1661FBF18D00}"/>
               </a:ext>
             </a:extLst>
           </p:cNvPr>
@@ -2547,7 +2547,7 @@
           <p:cNvPr id="4" name="テキスト プレースホルダー 3">
             <a:extLst>
               <a:ext uri="{FF2B5EF4-FFF2-40B4-BE49-F238E27FC236}">
-                <a16:creationId xmlns:a16="http://schemas.microsoft.com/office/drawing/2014/main" id="{E60751D3-A9F3-190B-F12C-5E2828510D72}"/>
+                <a16:creationId xmlns:a16="http://schemas.microsoft.com/office/drawing/2014/main" id="{081C287C-AC83-B2BD-4715-5D811953F1EE}"/>
               </a:ext>
             </a:extLst>
           </p:cNvPr>
@@ -2618,7 +2618,7 @@
           <p:cNvPr id="5" name="日付プレースホルダー 4">
             <a:extLst>
               <a:ext uri="{FF2B5EF4-FFF2-40B4-BE49-F238E27FC236}">
-                <a16:creationId xmlns:a16="http://schemas.microsoft.com/office/drawing/2014/main" id="{0DA816FB-DF71-C32D-8076-F105C9A5D5F6}"/>
+                <a16:creationId xmlns:a16="http://schemas.microsoft.com/office/drawing/2014/main" id="{D685F94F-AD58-29B2-E390-82B15EB2FE06}"/>
               </a:ext>
             </a:extLst>
           </p:cNvPr>
@@ -2634,7 +2634,7 @@
           <a:bodyPr/>
           <a:lstStyle/>
           <a:p>
-            <a:fld id="{FE520221-3195-4EB3-B38F-EF6E1ECCD26C}" type="datetimeFigureOut">
+            <a:fld id="{1E63A22F-7DA3-4DFC-B0E7-699664E6020E}" type="datetimeFigureOut">
               <a:rPr kumimoji="1" lang="ja-JP" altLang="en-US" smtClean="0"/>
               <a:t>2026/7/30</a:t>
             </a:fld>
@@ -2647,7 +2647,7 @@
           <p:cNvPr id="6" name="フッター プレースホルダー 5">
             <a:extLst>
               <a:ext uri="{FF2B5EF4-FFF2-40B4-BE49-F238E27FC236}">
-                <a16:creationId xmlns:a16="http://schemas.microsoft.com/office/drawing/2014/main" id="{B66EDB6D-F0D8-E9BA-70EA-DE6B91FF26F6}"/>
+                <a16:creationId xmlns:a16="http://schemas.microsoft.com/office/drawing/2014/main" id="{35F52991-9083-3F14-E104-A8E972A2DA55}"/>
               </a:ext>
             </a:extLst>
           </p:cNvPr>
@@ -2672,7 +2672,7 @@
           <p:cNvPr id="7" name="スライド番号プレースホルダー 6">
             <a:extLst>
               <a:ext uri="{FF2B5EF4-FFF2-40B4-BE49-F238E27FC236}">
-                <a16:creationId xmlns:a16="http://schemas.microsoft.com/office/drawing/2014/main" id="{11063A7F-F03C-6691-BA9A-AE733EE4DCE3}"/>
+                <a16:creationId xmlns:a16="http://schemas.microsoft.com/office/drawing/2014/main" id="{673A7888-0074-1B5D-54CD-B57410791C2F}"/>
               </a:ext>
             </a:extLst>
           </p:cNvPr>
@@ -2688,7 +2688,7 @@
           <a:bodyPr/>
           <a:lstStyle/>
           <a:p>
-            <a:fld id="{76CC2731-E6DF-4628-8FDC-A2B2A9FEE3CD}" type="slidenum">
+            <a:fld id="{A004027A-2514-4CCF-9CDD-0F55957BC748}" type="slidenum">
               <a:rPr kumimoji="1" lang="ja-JP" altLang="en-US" smtClean="0"/>
               <a:t>‹#›</a:t>
             </a:fld>
@@ -2699,7 +2699,7 @@
     </p:spTree>
     <p:extLst>
       <p:ext uri="{BB962C8B-B14F-4D97-AF65-F5344CB8AC3E}">
-        <p14:creationId xmlns:p14="http://schemas.microsoft.com/office/powerpoint/2010/main" val="3650075152"/>
+        <p14:creationId xmlns:p14="http://schemas.microsoft.com/office/powerpoint/2010/main" val="1168621300"/>
       </p:ext>
     </p:extLst>
   </p:cSld>
@@ -2731,7 +2731,7 @@
           <p:cNvPr id="2" name="タイトル 1">
             <a:extLst>
               <a:ext uri="{FF2B5EF4-FFF2-40B4-BE49-F238E27FC236}">
-                <a16:creationId xmlns:a16="http://schemas.microsoft.com/office/drawing/2014/main" id="{F9E5832F-ED06-CCDA-75FF-9A0BE447D396}"/>
+                <a16:creationId xmlns:a16="http://schemas.microsoft.com/office/drawing/2014/main" id="{260718AD-9A2D-2CB1-0653-5833B7B71134}"/>
               </a:ext>
             </a:extLst>
           </p:cNvPr>
@@ -2768,7 +2768,7 @@
           <p:cNvPr id="3" name="図プレースホルダー 2">
             <a:extLst>
               <a:ext uri="{FF2B5EF4-FFF2-40B4-BE49-F238E27FC236}">
-                <a16:creationId xmlns:a16="http://schemas.microsoft.com/office/drawing/2014/main" id="{A5E38F5B-62D8-2F9D-9BB5-E6005BEF8F4D}"/>
+                <a16:creationId xmlns:a16="http://schemas.microsoft.com/office/drawing/2014/main" id="{54DB6A05-8588-4759-F67C-66AF75665D50}"/>
               </a:ext>
             </a:extLst>
           </p:cNvPr>
@@ -2835,7 +2835,7 @@
           <p:cNvPr id="4" name="テキスト プレースホルダー 3">
             <a:extLst>
               <a:ext uri="{FF2B5EF4-FFF2-40B4-BE49-F238E27FC236}">
-                <a16:creationId xmlns:a16="http://schemas.microsoft.com/office/drawing/2014/main" id="{13C21555-C21E-69B0-ACBD-E43D070178EF}"/>
+                <a16:creationId xmlns:a16="http://schemas.microsoft.com/office/drawing/2014/main" id="{0CDE4EE1-23B6-D6C9-60F2-93D11B433F54}"/>
               </a:ext>
             </a:extLst>
           </p:cNvPr>
@@ -2906,7 +2906,7 @@
           <p:cNvPr id="5" name="日付プレースホルダー 4">
             <a:extLst>
               <a:ext uri="{FF2B5EF4-FFF2-40B4-BE49-F238E27FC236}">
-                <a16:creationId xmlns:a16="http://schemas.microsoft.com/office/drawing/2014/main" id="{A9D379B7-D78B-896C-3EA1-E4D38F597DF6}"/>
+                <a16:creationId xmlns:a16="http://schemas.microsoft.com/office/drawing/2014/main" id="{4A5833CA-6BA8-BC5B-AA05-BE86B929730F}"/>
               </a:ext>
             </a:extLst>
           </p:cNvPr>
@@ -2922,7 +2922,7 @@
           <a:bodyPr/>
           <a:lstStyle/>
           <a:p>
-            <a:fld id="{FE520221-3195-4EB3-B38F-EF6E1ECCD26C}" type="datetimeFigureOut">
+            <a:fld id="{1E63A22F-7DA3-4DFC-B0E7-699664E6020E}" type="datetimeFigureOut">
               <a:rPr kumimoji="1" lang="ja-JP" altLang="en-US" smtClean="0"/>
               <a:t>2026/7/30</a:t>
             </a:fld>
@@ -2935,7 +2935,7 @@
           <p:cNvPr id="6" name="フッター プレースホルダー 5">
             <a:extLst>
               <a:ext uri="{FF2B5EF4-FFF2-40B4-BE49-F238E27FC236}">
-                <a16:creationId xmlns:a16="http://schemas.microsoft.com/office/drawing/2014/main" id="{0BF14242-8B52-59DC-C53B-8708EC62A244}"/>
+                <a16:creationId xmlns:a16="http://schemas.microsoft.com/office/drawing/2014/main" id="{9FED3086-1BAD-5020-AEE0-DD96E893F0EE}"/>
               </a:ext>
             </a:extLst>
           </p:cNvPr>
@@ -2960,7 +2960,7 @@
           <p:cNvPr id="7" name="スライド番号プレースホルダー 6">
             <a:extLst>
               <a:ext uri="{FF2B5EF4-FFF2-40B4-BE49-F238E27FC236}">
-                <a16:creationId xmlns:a16="http://schemas.microsoft.com/office/drawing/2014/main" id="{E472759B-0198-F42F-AFFA-0F20FB6BEF09}"/>
+                <a16:creationId xmlns:a16="http://schemas.microsoft.com/office/drawing/2014/main" id="{51E9FBF3-8A3A-490C-EF88-E174DB4B06E2}"/>
               </a:ext>
             </a:extLst>
           </p:cNvPr>
@@ -2976,7 +2976,7 @@
           <a:bodyPr/>
           <a:lstStyle/>
           <a:p>
-            <a:fld id="{76CC2731-E6DF-4628-8FDC-A2B2A9FEE3CD}" type="slidenum">
+            <a:fld id="{A004027A-2514-4CCF-9CDD-0F55957BC748}" type="slidenum">
               <a:rPr kumimoji="1" lang="ja-JP" altLang="en-US" smtClean="0"/>
               <a:t>‹#›</a:t>
             </a:fld>
@@ -2987,7 +2987,7 @@
     </p:spTree>
     <p:extLst>
       <p:ext uri="{BB962C8B-B14F-4D97-AF65-F5344CB8AC3E}">
-        <p14:creationId xmlns:p14="http://schemas.microsoft.com/office/powerpoint/2010/main" val="2385161905"/>
+        <p14:creationId xmlns:p14="http://schemas.microsoft.com/office/powerpoint/2010/main" val="262901651"/>
       </p:ext>
     </p:extLst>
   </p:cSld>
@@ -3024,7 +3024,7 @@
           <p:cNvPr id="2" name="タイトル プレースホルダー 1">
             <a:extLst>
               <a:ext uri="{FF2B5EF4-FFF2-40B4-BE49-F238E27FC236}">
-                <a16:creationId xmlns:a16="http://schemas.microsoft.com/office/drawing/2014/main" id="{D8381A16-70AF-8E5F-887D-CE4AD5DDF4FB}"/>
+                <a16:creationId xmlns:a16="http://schemas.microsoft.com/office/drawing/2014/main" id="{F751449D-0FF6-8F58-7227-C09EE8475004}"/>
               </a:ext>
             </a:extLst>
           </p:cNvPr>
@@ -3062,7 +3062,7 @@
           <p:cNvPr id="3" name="テキスト プレースホルダー 2">
             <a:extLst>
               <a:ext uri="{FF2B5EF4-FFF2-40B4-BE49-F238E27FC236}">
-                <a16:creationId xmlns:a16="http://schemas.microsoft.com/office/drawing/2014/main" id="{461F691E-263E-617A-A8AB-196DD7A9569C}"/>
+                <a16:creationId xmlns:a16="http://schemas.microsoft.com/office/drawing/2014/main" id="{4D6F5224-1C72-49B1-2EC5-AA5D5D2E9ED2}"/>
               </a:ext>
             </a:extLst>
           </p:cNvPr>
@@ -3161,7 +3161,7 @@
           <p:cNvPr id="4" name="日付プレースホルダー 3">
             <a:extLst>
               <a:ext uri="{FF2B5EF4-FFF2-40B4-BE49-F238E27FC236}">
-                <a16:creationId xmlns:a16="http://schemas.microsoft.com/office/drawing/2014/main" id="{C13D9C84-E55A-7165-3C6A-80CBDEEDCD1F}"/>
+                <a16:creationId xmlns:a16="http://schemas.microsoft.com/office/drawing/2014/main" id="{5488B68E-0EF5-9E19-DDDD-ADF329C95A67}"/>
               </a:ext>
             </a:extLst>
           </p:cNvPr>
@@ -3195,7 +3195,7 @@
             </a:lvl1pPr>
           </a:lstStyle>
           <a:p>
-            <a:fld id="{FE520221-3195-4EB3-B38F-EF6E1ECCD26C}" type="datetimeFigureOut">
+            <a:fld id="{1E63A22F-7DA3-4DFC-B0E7-699664E6020E}" type="datetimeFigureOut">
               <a:rPr kumimoji="1" lang="ja-JP" altLang="en-US" smtClean="0"/>
               <a:t>2026/7/30</a:t>
             </a:fld>
@@ -3208,7 +3208,7 @@
           <p:cNvPr id="5" name="フッター プレースホルダー 4">
             <a:extLst>
               <a:ext uri="{FF2B5EF4-FFF2-40B4-BE49-F238E27FC236}">
-                <a16:creationId xmlns:a16="http://schemas.microsoft.com/office/drawing/2014/main" id="{0364B50D-7849-86A1-066B-2410C4D7465B}"/>
+                <a16:creationId xmlns:a16="http://schemas.microsoft.com/office/drawing/2014/main" id="{0CF44A7E-9ECB-1411-B4E1-BB6F49E60A96}"/>
               </a:ext>
             </a:extLst>
           </p:cNvPr>
@@ -3251,7 +3251,7 @@
           <p:cNvPr id="6" name="スライド番号プレースホルダー 5">
             <a:extLst>
               <a:ext uri="{FF2B5EF4-FFF2-40B4-BE49-F238E27FC236}">
-                <a16:creationId xmlns:a16="http://schemas.microsoft.com/office/drawing/2014/main" id="{964D4AA5-C127-D025-D314-97D2D3A85BF3}"/>
+                <a16:creationId xmlns:a16="http://schemas.microsoft.com/office/drawing/2014/main" id="{C10E7E0A-D168-D36E-04C9-5F64F9BBB123}"/>
               </a:ext>
             </a:extLst>
           </p:cNvPr>
@@ -3285,7 +3285,7 @@
             </a:lvl1pPr>
           </a:lstStyle>
           <a:p>
-            <a:fld id="{76CC2731-E6DF-4628-8FDC-A2B2A9FEE3CD}" type="slidenum">
+            <a:fld id="{A004027A-2514-4CCF-9CDD-0F55957BC748}" type="slidenum">
               <a:rPr kumimoji="1" lang="ja-JP" altLang="en-US" smtClean="0"/>
               <a:t>‹#›</a:t>
             </a:fld>
@@ -3296,7 +3296,7 @@
     </p:spTree>
     <p:extLst>
       <p:ext uri="{BB962C8B-B14F-4D97-AF65-F5344CB8AC3E}">
-        <p14:creationId xmlns:p14="http://schemas.microsoft.com/office/powerpoint/2010/main" val="2688483341"/>
+        <p14:creationId xmlns:p14="http://schemas.microsoft.com/office/powerpoint/2010/main" val="451496842"/>
       </p:ext>
     </p:extLst>
   </p:cSld>
@@ -3619,7 +3619,7 @@
           <p:cNvPr id="2" name="テキスト ボックス 1">
             <a:extLst>
               <a:ext uri="{FF2B5EF4-FFF2-40B4-BE49-F238E27FC236}">
-                <a16:creationId xmlns:a16="http://schemas.microsoft.com/office/drawing/2014/main" id="{DB29B1AE-9BE4-FE3F-5438-2BF729F1A0C2}"/>
+                <a16:creationId xmlns:a16="http://schemas.microsoft.com/office/drawing/2014/main" id="{FF0A6139-5AAF-96F5-F3CA-520DD866C0D5}"/>
               </a:ext>
             </a:extLst>
           </p:cNvPr>
@@ -3665,7 +3665,7 @@
           <p:cNvPr id="3" name="テキスト ボックス 2">
             <a:extLst>
               <a:ext uri="{FF2B5EF4-FFF2-40B4-BE49-F238E27FC236}">
-                <a16:creationId xmlns:a16="http://schemas.microsoft.com/office/drawing/2014/main" id="{B7C1A988-575B-F19D-E3F9-95392D2CE4A9}"/>
+                <a16:creationId xmlns:a16="http://schemas.microsoft.com/office/drawing/2014/main" id="{CE9857BF-EE38-7556-1BB8-635625EC8795}"/>
               </a:ext>
             </a:extLst>
           </p:cNvPr>
@@ -3714,7 +3714,7 @@
           <p:cNvPr id="4" name="テキスト ボックス 3">
             <a:extLst>
               <a:ext uri="{FF2B5EF4-FFF2-40B4-BE49-F238E27FC236}">
-                <a16:creationId xmlns:a16="http://schemas.microsoft.com/office/drawing/2014/main" id="{67D5CCD8-109F-23AB-0210-7B4D855F345F}"/>
+                <a16:creationId xmlns:a16="http://schemas.microsoft.com/office/drawing/2014/main" id="{AA941CC3-75FD-0771-15DA-3331CFF094F6}"/>
               </a:ext>
             </a:extLst>
           </p:cNvPr>
@@ -3754,7 +3754,7 @@
           <p:cNvPr id="5" name="テキスト ボックス 4">
             <a:extLst>
               <a:ext uri="{FF2B5EF4-FFF2-40B4-BE49-F238E27FC236}">
-                <a16:creationId xmlns:a16="http://schemas.microsoft.com/office/drawing/2014/main" id="{23E526D1-7DE4-300D-2B2E-0902DB610DC8}"/>
+                <a16:creationId xmlns:a16="http://schemas.microsoft.com/office/drawing/2014/main" id="{F369E187-A3FD-21D1-A097-FEDB74CED866}"/>
               </a:ext>
             </a:extLst>
           </p:cNvPr>
@@ -3801,7 +3801,7 @@
             <a:hlinkClick r:id="" action="ppaction://media"/>
             <a:extLst>
               <a:ext uri="{FF2B5EF4-FFF2-40B4-BE49-F238E27FC236}">
-                <a16:creationId xmlns:a16="http://schemas.microsoft.com/office/drawing/2014/main" id="{2C42BD42-AC92-014C-3687-54EDB94B9419}"/>
+                <a16:creationId xmlns:a16="http://schemas.microsoft.com/office/drawing/2014/main" id="{078D5E2C-9C94-B6B7-69B8-0E8C9906CF64}"/>
               </a:ext>
             </a:extLst>
           </p:cNvPr>
@@ -3836,7 +3836,7 @@
     </p:spTree>
     <p:extLst>
       <p:ext uri="{BB962C8B-B14F-4D97-AF65-F5344CB8AC3E}">
-        <p14:creationId xmlns:p14="http://schemas.microsoft.com/office/powerpoint/2010/main" val="3618784860"/>
+        <p14:creationId xmlns:p14="http://schemas.microsoft.com/office/powerpoint/2010/main" val="2216108203"/>
       </p:ext>
     </p:extLst>
   </p:cSld>
@@ -3960,7 +3960,7 @@
           <p:cNvPr id="2" name="テキスト ボックス 1">
             <a:extLst>
               <a:ext uri="{FF2B5EF4-FFF2-40B4-BE49-F238E27FC236}">
-                <a16:creationId xmlns:a16="http://schemas.microsoft.com/office/drawing/2014/main" id="{643C2075-0061-E54E-FFD2-EF375E5AFF51}"/>
+                <a16:creationId xmlns:a16="http://schemas.microsoft.com/office/drawing/2014/main" id="{8D0EFA09-2982-A1D5-F057-D3DAAD7D312B}"/>
               </a:ext>
             </a:extLst>
           </p:cNvPr>
@@ -4006,7 +4006,7 @@
           <p:cNvPr id="3" name="テキスト ボックス 2">
             <a:extLst>
               <a:ext uri="{FF2B5EF4-FFF2-40B4-BE49-F238E27FC236}">
-                <a16:creationId xmlns:a16="http://schemas.microsoft.com/office/drawing/2014/main" id="{01C73817-B4D3-5EC2-F3F5-534609F5A28C}"/>
+                <a16:creationId xmlns:a16="http://schemas.microsoft.com/office/drawing/2014/main" id="{913DF6AF-E67A-F59E-17D1-717B7359832F}"/>
               </a:ext>
             </a:extLst>
           </p:cNvPr>
@@ -4046,7 +4046,7 @@
           <p:cNvPr id="4" name="テキスト ボックス 3">
             <a:extLst>
               <a:ext uri="{FF2B5EF4-FFF2-40B4-BE49-F238E27FC236}">
-                <a16:creationId xmlns:a16="http://schemas.microsoft.com/office/drawing/2014/main" id="{D328364A-6CA0-E54B-1523-2ADE2A27F5EB}"/>
+                <a16:creationId xmlns:a16="http://schemas.microsoft.com/office/drawing/2014/main" id="{835AD717-C497-B5E2-9100-34743BEEE2AC}"/>
               </a:ext>
             </a:extLst>
           </p:cNvPr>
@@ -4128,7 +4128,7 @@
           <p:cNvPr id="5" name="テキスト ボックス 4">
             <a:extLst>
               <a:ext uri="{FF2B5EF4-FFF2-40B4-BE49-F238E27FC236}">
-                <a16:creationId xmlns:a16="http://schemas.microsoft.com/office/drawing/2014/main" id="{B9029772-B2B6-1C60-8346-F9A52E1E8CB7}"/>
+                <a16:creationId xmlns:a16="http://schemas.microsoft.com/office/drawing/2014/main" id="{60298BBC-FCB7-E919-F703-F91BE58B2F91}"/>
               </a:ext>
             </a:extLst>
           </p:cNvPr>
@@ -4175,7 +4175,7 @@
             <a:hlinkClick r:id="" action="ppaction://media"/>
             <a:extLst>
               <a:ext uri="{FF2B5EF4-FFF2-40B4-BE49-F238E27FC236}">
-                <a16:creationId xmlns:a16="http://schemas.microsoft.com/office/drawing/2014/main" id="{7B42D79C-46B8-A01B-5D34-C99E24CE7E5C}"/>
+                <a16:creationId xmlns:a16="http://schemas.microsoft.com/office/drawing/2014/main" id="{4CCB83F8-C30F-0B30-FBEA-A7571BCD7B97}"/>
               </a:ext>
             </a:extLst>
           </p:cNvPr>
@@ -4210,7 +4210,7 @@
     </p:spTree>
     <p:extLst>
       <p:ext uri="{BB962C8B-B14F-4D97-AF65-F5344CB8AC3E}">
-        <p14:creationId xmlns:p14="http://schemas.microsoft.com/office/powerpoint/2010/main" val="3654484095"/>
+        <p14:creationId xmlns:p14="http://schemas.microsoft.com/office/powerpoint/2010/main" val="1860451481"/>
       </p:ext>
     </p:extLst>
   </p:cSld>
@@ -4334,7 +4334,7 @@
           <p:cNvPr id="2" name="テキスト ボックス 1">
             <a:extLst>
               <a:ext uri="{FF2B5EF4-FFF2-40B4-BE49-F238E27FC236}">
-                <a16:creationId xmlns:a16="http://schemas.microsoft.com/office/drawing/2014/main" id="{984D8ADD-5D8B-62C7-34B5-D936A86D0724}"/>
+                <a16:creationId xmlns:a16="http://schemas.microsoft.com/office/drawing/2014/main" id="{8638B802-0122-76CA-D87E-103A37E15021}"/>
               </a:ext>
             </a:extLst>
           </p:cNvPr>
@@ -4380,7 +4380,7 @@
           <p:cNvPr id="3" name="テキスト ボックス 2">
             <a:extLst>
               <a:ext uri="{FF2B5EF4-FFF2-40B4-BE49-F238E27FC236}">
-                <a16:creationId xmlns:a16="http://schemas.microsoft.com/office/drawing/2014/main" id="{9FA9756D-C157-C787-B5BA-E16D98A2E572}"/>
+                <a16:creationId xmlns:a16="http://schemas.microsoft.com/office/drawing/2014/main" id="{64C0CB06-D204-085A-E85D-A6728CFFF78A}"/>
               </a:ext>
             </a:extLst>
           </p:cNvPr>
@@ -4420,7 +4420,7 @@
           <p:cNvPr id="4" name="テキスト ボックス 3">
             <a:extLst>
               <a:ext uri="{FF2B5EF4-FFF2-40B4-BE49-F238E27FC236}">
-                <a16:creationId xmlns:a16="http://schemas.microsoft.com/office/drawing/2014/main" id="{6EA9EEF8-8B34-3886-E89C-43D86590AA77}"/>
+                <a16:creationId xmlns:a16="http://schemas.microsoft.com/office/drawing/2014/main" id="{1F9247DC-F319-F2FC-EA2C-FD35691DB17D}"/>
               </a:ext>
             </a:extLst>
           </p:cNvPr>
@@ -4515,7 +4515,7 @@
           <p:cNvPr id="5" name="テキスト ボックス 4">
             <a:extLst>
               <a:ext uri="{FF2B5EF4-FFF2-40B4-BE49-F238E27FC236}">
-                <a16:creationId xmlns:a16="http://schemas.microsoft.com/office/drawing/2014/main" id="{5A21B68B-F0CB-DDF8-C179-39D5F467454C}"/>
+                <a16:creationId xmlns:a16="http://schemas.microsoft.com/office/drawing/2014/main" id="{28AFE817-470C-A6FD-EA66-CFBE78786F52}"/>
               </a:ext>
             </a:extLst>
           </p:cNvPr>
@@ -4562,7 +4562,7 @@
             <a:hlinkClick r:id="" action="ppaction://media"/>
             <a:extLst>
               <a:ext uri="{FF2B5EF4-FFF2-40B4-BE49-F238E27FC236}">
-                <a16:creationId xmlns:a16="http://schemas.microsoft.com/office/drawing/2014/main" id="{A20B45B2-0ED3-1F10-5954-15A74566B2BE}"/>
+                <a16:creationId xmlns:a16="http://schemas.microsoft.com/office/drawing/2014/main" id="{A6AC6E80-AE12-6A99-A9BB-DE5199556B88}"/>
               </a:ext>
             </a:extLst>
           </p:cNvPr>
@@ -4597,7 +4597,7 @@
     </p:spTree>
     <p:extLst>
       <p:ext uri="{BB962C8B-B14F-4D97-AF65-F5344CB8AC3E}">
-        <p14:creationId xmlns:p14="http://schemas.microsoft.com/office/powerpoint/2010/main" val="2102569394"/>
+        <p14:creationId xmlns:p14="http://schemas.microsoft.com/office/powerpoint/2010/main" val="3020556067"/>
       </p:ext>
     </p:extLst>
   </p:cSld>
@@ -4721,7 +4721,7 @@
           <p:cNvPr id="2" name="テキスト ボックス 1">
             <a:extLst>
               <a:ext uri="{FF2B5EF4-FFF2-40B4-BE49-F238E27FC236}">
-                <a16:creationId xmlns:a16="http://schemas.microsoft.com/office/drawing/2014/main" id="{E94B1298-A63A-7560-EBD5-894481977379}"/>
+                <a16:creationId xmlns:a16="http://schemas.microsoft.com/office/drawing/2014/main" id="{587773CC-409B-424A-4E0C-DA7020681E00}"/>
               </a:ext>
             </a:extLst>
           </p:cNvPr>
@@ -4767,7 +4767,7 @@
           <p:cNvPr id="3" name="テキスト ボックス 2">
             <a:extLst>
               <a:ext uri="{FF2B5EF4-FFF2-40B4-BE49-F238E27FC236}">
-                <a16:creationId xmlns:a16="http://schemas.microsoft.com/office/drawing/2014/main" id="{603B2476-3E77-00FB-88A9-66CE798347B4}"/>
+                <a16:creationId xmlns:a16="http://schemas.microsoft.com/office/drawing/2014/main" id="{09187421-8CAB-A6E4-C1E1-078F745E8055}"/>
               </a:ext>
             </a:extLst>
           </p:cNvPr>
@@ -4807,7 +4807,7 @@
           <p:cNvPr id="4" name="テキスト ボックス 3">
             <a:extLst>
               <a:ext uri="{FF2B5EF4-FFF2-40B4-BE49-F238E27FC236}">
-                <a16:creationId xmlns:a16="http://schemas.microsoft.com/office/drawing/2014/main" id="{841D6DFB-1AFF-CDA2-9F1F-C7B2B83B008F}"/>
+                <a16:creationId xmlns:a16="http://schemas.microsoft.com/office/drawing/2014/main" id="{B282872C-17E3-5157-1804-F282238FD49B}"/>
               </a:ext>
             </a:extLst>
           </p:cNvPr>
@@ -4917,7 +4917,7 @@
           <p:cNvPr id="5" name="テキスト ボックス 4">
             <a:extLst>
               <a:ext uri="{FF2B5EF4-FFF2-40B4-BE49-F238E27FC236}">
-                <a16:creationId xmlns:a16="http://schemas.microsoft.com/office/drawing/2014/main" id="{05A43622-3405-4F0D-D624-3A4AF1358E5B}"/>
+                <a16:creationId xmlns:a16="http://schemas.microsoft.com/office/drawing/2014/main" id="{1AEA2144-37C7-BCE1-D2D9-F9BE04D74F52}"/>
               </a:ext>
             </a:extLst>
           </p:cNvPr>
@@ -4964,7 +4964,7 @@
             <a:hlinkClick r:id="" action="ppaction://media"/>
             <a:extLst>
               <a:ext uri="{FF2B5EF4-FFF2-40B4-BE49-F238E27FC236}">
-                <a16:creationId xmlns:a16="http://schemas.microsoft.com/office/drawing/2014/main" id="{1F956A08-BCA4-FB44-6CBA-D78A54474806}"/>
+                <a16:creationId xmlns:a16="http://schemas.microsoft.com/office/drawing/2014/main" id="{803C57AA-1C94-AFF2-6BFF-7CE60789E4C6}"/>
               </a:ext>
             </a:extLst>
           </p:cNvPr>
@@ -4999,7 +4999,7 @@
     </p:spTree>
     <p:extLst>
       <p:ext uri="{BB962C8B-B14F-4D97-AF65-F5344CB8AC3E}">
-        <p14:creationId xmlns:p14="http://schemas.microsoft.com/office/powerpoint/2010/main" val="2867394919"/>
+        <p14:creationId xmlns:p14="http://schemas.microsoft.com/office/powerpoint/2010/main" val="3156744643"/>
       </p:ext>
     </p:extLst>
   </p:cSld>
@@ -5123,7 +5123,7 @@
           <p:cNvPr id="2" name="テキスト ボックス 1">
             <a:extLst>
               <a:ext uri="{FF2B5EF4-FFF2-40B4-BE49-F238E27FC236}">
-                <a16:creationId xmlns:a16="http://schemas.microsoft.com/office/drawing/2014/main" id="{D853B949-33B5-9D55-495E-DEC09F0E563E}"/>
+                <a16:creationId xmlns:a16="http://schemas.microsoft.com/office/drawing/2014/main" id="{FF687986-3C2F-FD43-0B70-DFC6ADB88A0E}"/>
               </a:ext>
             </a:extLst>
           </p:cNvPr>
@@ -5169,7 +5169,7 @@
           <p:cNvPr id="3" name="テキスト ボックス 2">
             <a:extLst>
               <a:ext uri="{FF2B5EF4-FFF2-40B4-BE49-F238E27FC236}">
-                <a16:creationId xmlns:a16="http://schemas.microsoft.com/office/drawing/2014/main" id="{EB1021B5-9C5D-E803-C360-F49730DC7AC9}"/>
+                <a16:creationId xmlns:a16="http://schemas.microsoft.com/office/drawing/2014/main" id="{5395E6CF-61F0-6366-0AD4-1710F1196326}"/>
               </a:ext>
             </a:extLst>
           </p:cNvPr>
@@ -5209,7 +5209,7 @@
           <p:cNvPr id="4" name="テキスト ボックス 3">
             <a:extLst>
               <a:ext uri="{FF2B5EF4-FFF2-40B4-BE49-F238E27FC236}">
-                <a16:creationId xmlns:a16="http://schemas.microsoft.com/office/drawing/2014/main" id="{B14FCEED-3072-0858-53E4-CFA8E57855AD}"/>
+                <a16:creationId xmlns:a16="http://schemas.microsoft.com/office/drawing/2014/main" id="{ED727185-F127-CDF3-6577-73CF79F3F719}"/>
               </a:ext>
             </a:extLst>
           </p:cNvPr>
@@ -5233,20 +5233,14 @@
           <a:lstStyle/>
           <a:p>
             <a:r>
-              <a:rPr kumimoji="1" lang="en-US" altLang="ja-JP" sz="2000">
+              <a:rPr kumimoji="1" lang="ja-JP" altLang="en-US" sz="2000">
                 <a:solidFill>
                   <a:srgbClr val="333333"/>
                 </a:solidFill>
                 <a:latin typeface="Arial" panose="020B0604020202020204" pitchFamily="34" charset="0"/>
               </a:rPr>
-              <a:t>Set confirmed custom domain</a:t>
-            </a:r>
-            <a:endParaRPr kumimoji="1" lang="ja-JP" altLang="en-US" sz="2000">
-              <a:solidFill>
-                <a:srgbClr val="333333"/>
-              </a:solidFill>
-              <a:latin typeface="Arial" panose="020B0604020202020204" pitchFamily="34" charset="0"/>
-            </a:endParaRPr>
+              <a:t>直近のコミットでは、実装の見直しと継続的な改善が行われました。</a:t>
+            </a:r>
           </a:p>
         </p:txBody>
       </p:sp>
@@ -5255,7 +5249,7 @@
           <p:cNvPr id="5" name="テキスト ボックス 4">
             <a:extLst>
               <a:ext uri="{FF2B5EF4-FFF2-40B4-BE49-F238E27FC236}">
-                <a16:creationId xmlns:a16="http://schemas.microsoft.com/office/drawing/2014/main" id="{8000CF08-9F36-60CE-3ED1-7575FB3219A9}"/>
+                <a16:creationId xmlns:a16="http://schemas.microsoft.com/office/drawing/2014/main" id="{E96154F9-AE8F-6910-3366-31D5608A69D7}"/>
               </a:ext>
             </a:extLst>
           </p:cNvPr>
@@ -5302,7 +5296,7 @@
             <a:hlinkClick r:id="" action="ppaction://media"/>
             <a:extLst>
               <a:ext uri="{FF2B5EF4-FFF2-40B4-BE49-F238E27FC236}">
-                <a16:creationId xmlns:a16="http://schemas.microsoft.com/office/drawing/2014/main" id="{7B0A191A-5746-F28B-04B9-B58F6CD5B18B}"/>
+                <a16:creationId xmlns:a16="http://schemas.microsoft.com/office/drawing/2014/main" id="{34478758-C4F6-BCF4-83BF-0512CA826962}"/>
               </a:ext>
             </a:extLst>
           </p:cNvPr>
@@ -5337,7 +5331,7 @@
     </p:spTree>
     <p:extLst>
       <p:ext uri="{BB962C8B-B14F-4D97-AF65-F5344CB8AC3E}">
-        <p14:creationId xmlns:p14="http://schemas.microsoft.com/office/powerpoint/2010/main" val="3166438509"/>
+        <p14:creationId xmlns:p14="http://schemas.microsoft.com/office/powerpoint/2010/main" val="4249206732"/>
       </p:ext>
     </p:extLst>
   </p:cSld>
@@ -5380,7 +5374,7 @@
                                   <p:childTnLst>
                                     <p:cmd type="call" cmd="playFrom(0.0)">
                                       <p:cBhvr>
-                                        <p:cTn id="6" dur="6451" fill="hold"/>
+                                        <p:cTn id="6" dur="6076" fill="hold"/>
                                         <p:tgtEl>
                                           <p:spTgt spid="6"/>
                                         </p:tgtEl>
@@ -5461,7 +5455,7 @@
           <p:cNvPr id="2" name="テキスト ボックス 1">
             <a:extLst>
               <a:ext uri="{FF2B5EF4-FFF2-40B4-BE49-F238E27FC236}">
-                <a16:creationId xmlns:a16="http://schemas.microsoft.com/office/drawing/2014/main" id="{A646CD74-3EAF-C4CA-13B8-8266972BD148}"/>
+                <a16:creationId xmlns:a16="http://schemas.microsoft.com/office/drawing/2014/main" id="{A57CCB46-4541-BBE9-BF4B-507FA9A8888E}"/>
               </a:ext>
             </a:extLst>
           </p:cNvPr>
@@ -5507,7 +5501,7 @@
           <p:cNvPr id="3" name="テキスト ボックス 2">
             <a:extLst>
               <a:ext uri="{FF2B5EF4-FFF2-40B4-BE49-F238E27FC236}">
-                <a16:creationId xmlns:a16="http://schemas.microsoft.com/office/drawing/2014/main" id="{8E8F460E-D393-F443-E7EA-DFA2EC2DF63B}"/>
+                <a16:creationId xmlns:a16="http://schemas.microsoft.com/office/drawing/2014/main" id="{CEFE548F-4FF8-1475-65CF-1BC82129699E}"/>
               </a:ext>
             </a:extLst>
           </p:cNvPr>
@@ -5547,7 +5541,7 @@
           <p:cNvPr id="4" name="テキスト ボックス 3">
             <a:extLst>
               <a:ext uri="{FF2B5EF4-FFF2-40B4-BE49-F238E27FC236}">
-                <a16:creationId xmlns:a16="http://schemas.microsoft.com/office/drawing/2014/main" id="{B676486F-B42A-CE08-F904-8405398B35AD}"/>
+                <a16:creationId xmlns:a16="http://schemas.microsoft.com/office/drawing/2014/main" id="{F4EB4ABD-063F-4BE2-8B87-A68BBB95FC61}"/>
               </a:ext>
             </a:extLst>
           </p:cNvPr>
@@ -5612,7 +5606,7 @@
           <p:cNvPr id="5" name="テキスト ボックス 4">
             <a:extLst>
               <a:ext uri="{FF2B5EF4-FFF2-40B4-BE49-F238E27FC236}">
-                <a16:creationId xmlns:a16="http://schemas.microsoft.com/office/drawing/2014/main" id="{A0A9C182-8DA6-6D34-46F6-5497329D1247}"/>
+                <a16:creationId xmlns:a16="http://schemas.microsoft.com/office/drawing/2014/main" id="{3BE16B2F-CF11-41F5-78BA-FEA06EF0C1A0}"/>
               </a:ext>
             </a:extLst>
           </p:cNvPr>
@@ -5659,7 +5653,7 @@
             <a:hlinkClick r:id="" action="ppaction://media"/>
             <a:extLst>
               <a:ext uri="{FF2B5EF4-FFF2-40B4-BE49-F238E27FC236}">
-                <a16:creationId xmlns:a16="http://schemas.microsoft.com/office/drawing/2014/main" id="{1F393C82-F7FF-ED37-ABE7-2527C2D32589}"/>
+                <a16:creationId xmlns:a16="http://schemas.microsoft.com/office/drawing/2014/main" id="{0B974D7D-917D-001E-ED58-3B9FE647D627}"/>
               </a:ext>
             </a:extLst>
           </p:cNvPr>
@@ -5694,7 +5688,7 @@
     </p:spTree>
     <p:extLst>
       <p:ext uri="{BB962C8B-B14F-4D97-AF65-F5344CB8AC3E}">
-        <p14:creationId xmlns:p14="http://schemas.microsoft.com/office/powerpoint/2010/main" val="1566754755"/>
+        <p14:creationId xmlns:p14="http://schemas.microsoft.com/office/powerpoint/2010/main" val="21975457"/>
       </p:ext>
     </p:extLst>
   </p:cSld>

</xml_diff>